<commit_message>
Require classical citations in Luna coaching and finalize presentation decks
</commit_message>
<xml_diff>
--- a/presentations/Hanui-Relay-10min.pptx
+++ b/presentations/Hanui-Relay-10min.pptx
@@ -521,7 +521,7 @@
           <a:p/>
           <a:p>
             <a:r>
-              <a:t>“Hanui Relay는 한의사의 진단·평가와 생활 지침을 바탕으로 AI가 먼저 확인 질문을 하고, 환자 답변을 원문 근거와 14일 내원 리포트로 잇는 프로토타입입니다. Track 2로 출품합니다.”</a:t>
+              <a:t>“Hanui Relay는 한의사의 진단·생활 지침을 바탕으로 에이전트가 앱 안에서 먼저 대화를 시작하고, 환자 답변을 다음 방문까지 관리하는 프로토타입입니다. Track 2로 출품합니다.”</a:t>
             </a:r>
           </a:p>
         </p:txBody>
@@ -749,7 +749,7 @@
           <a:p/>
           <a:p>
             <a:r>
-              <a:t>“76개 단위 테스트를 통과했습니다. 실제 Luna 계정으로 선행 질문·환자 답변·코칭의 연결 1회, 지침 대화 4턴, 달력 8턴, 새 고문헌 번역 1턴을 확인했습니다. 환자 발언에 없는 수치를 추측하지 않는 규칙과 실패 시 되돌림도 검사했습니다. 14일·병원·환자는 합성 자료이며 실제 사용자 편익과 임상 해석은 아직 검증하지 않았습니다.”</a:t>
+              <a:t>“80개 단위 테스트를 통과했습니다. 실제 Luna 계정으로 선행 질문·환자 답변·코칭의 연결 1회, 지침 대화 4턴, 달력 8턴, 새 고문헌 번역 1턴을 확인했습니다. 환자 발언에 없는 수치를 추측하지 않는 규칙과 실패 시 되돌림도 검사했습니다. 14일·병원·환자는 합성 자료이며 실제 사용자 편익과 임상 해석은 아직 검증하지 않았습니다.”</a:t>
             </a:r>
           </a:p>
         </p:txBody>
@@ -825,7 +825,7 @@
           <a:p/>
           <a:p>
             <a:r>
-              <a:t>“Codex가 Python 서버, DB, UI, 검색, 테스트와 자료 정리를 맡고, 원전 판본과 인용 위치, 환자 문장의 연결, 모바일 동작을 다시 대조했습니다. 사용자 피드백에 따라 기능 범위를 핵심 흐름에 집중하고, 대화창을 키우고 보조정보를 접었으며 한국어 해석을 먼저 보이게 했습니다. 상충 기록 보류와 예약 상태 구분도 개선했습니다.”</a:t>
+              <a:t>“서브 에이전트로 고전 문헌탐색, 메인: UI·백엔드 구현을 진행했습니다. 메인 Codex가 수집 원전 판본과 실제 인용 문자 위치, 환자 원문·날짜·수치를 대조하고 단위·UI·실제 Luna 연동을 검증했습니다. 모바일 넘침·대비와 실패 복원도 확인했습니다. 사용자 가독성 피드백으로 대화창을 키우고 덜 중요한 정보는 접었습니다. 상충 발언은 보류하며 질문만으로 환자 사실을 만들지 않습니다.”</a:t>
             </a:r>
           </a:p>
         </p:txBody>
@@ -901,7 +901,7 @@
           <a:p/>
           <a:p>
             <a:r>
-              <a:t>“잠재 도입·비용 주체는 한의원, 사용자는 환자입니다. 진료 후 지침 입력, 환자 대화, 원문 근거 리포트 확인으로 운영합니다. 지침 변경과 재방문마다 기록을 이어 쓸 수 있습니다. 확인 시간과 반복 질문 부담 감소는 가설이므로 작은 파일럿에서 확인 시간, 재사용률, 모델 호출 비용을 측정하겠습니다. 질문 받겠습니다.”</a:t>
+              <a:t>“잠재 도입 주체는 한의원이고 환자가 사용자입니다. 재방문마다 지침과 기록을 이어 확인합니다. 이 구조는 현대의학의 다른 분야에도 확장할 계획입니다. 그때는 해당 분야의 검증된 자료와 전문의 지침으로 교체해야 합니다. 현재는 한의학 프로토타입이며 도입 가치와 비용은 파일럿에서 측정하겠습니다. 질문 받겠습니다.”</a:t>
             </a:r>
           </a:p>
         </p:txBody>
@@ -1053,7 +1053,7 @@
           <a:p/>
           <a:p>
             <a:r>
-              <a:t>“한의학을 선택한 이유는 생활습관 지침이 중요하고, 한자 원전의 정보 장벽이 높으며, 환자와 한의사가 반복적으로 만나는 접점이 있기 때문입니다. 원전은 역사 자료입니다. 그 내용을 현대 임상 효능이나 개인별 처방 근거로 섞지 않습니다.”</a:t>
+              <a:t>“한의학에서 시작한 핵심 이유는 고문헌 원전 자체의 저작권이 만료되어 활용 가능하기 때문입니다. 다만 현대 번역·편집본은 별도 권리가 있고 공개 전사본의 이용 조건도 지켜야 합니다. 한자 원문을 한국어로 읽고 출처를 확인할 수 있게 하며 생활 지침과 이어 줍니다. 역사 기록을 임상 효능으로 주장하지 않습니다.”</a:t>
             </a:r>
           </a:p>
         </p:txBody>
@@ -1129,7 +1129,7 @@
           <a:p/>
           <a:p>
             <a:r>
-              <a:t>“사용 흐름은 네 단계입니다. 한의사가 진단·평가와 생활 지침 원문을 입력합니다. Hanui가 그 맥락으로 먼저 확인 질문을 하고 환자가 답합니다. 답변은 실천 기록·짧은 코칭과 고문헌 원문 탐색으로 이어집니다. 14일 리포트를 만들고 다음 방문을 준비합니다. 대화와 기록은 세션별 SQLite에 남습니다.”</a:t>
+              <a:t>“공통 구조는 의사의 지침, 앱 안에서 먼저 말을 거는 에이전트, 환자의 생활 답변, 근거 확인, 다음 내원 리포트입니다. 지금은 한의사가 진단·지침을 입력하면 Hanui가 먼저 질문합니다. 환자 답변을 기록·코칭하고 고문헌 원문과 연결해 14일 리포트를 만듭니다.”</a:t>
             </a:r>
           </a:p>
         </p:txBody>
@@ -1205,7 +1205,7 @@
           <a:p/>
           <a:p>
             <a:r>
-              <a:t>“서비스 모델은 현재 ChatGPT 로그인으로 호출하는 GPT-6 Luna, high입니다. 의료진이 입력한 평가를 맥락으로 첫 질문을 고르고, 답변에서 기록 후보와 DB 검색어를 정합니다. 필요하면 OpenAI 웹 검색으로 공개 병원 정보를 찾습니다. 서버는 환자 원문의 날짜·수치를 재계산하고 DB 인용 문자열·위치, 대화 소유권과 일정 상태를 확인합니다. AI는 의료진 평가를 임의로 갱신하거나 진단하지 않습니다.”</a:t>
+              <a:t>“서비스 모델은 현재 ChatGPT 로그인으로 호출하는 GPT-6 Luna, high입니다. 의료진 평가로 첫 질문을 고르고, 환자 답변에서 기록 후보와 DB 검색어를 정합니다. 서버는 환자 원문의 날짜·수치를 재계산하고 고문헌 인용 문자열·위치를 확인합니다. 모든 Luna 답변에서 고전 원문을 찾고 검증된 인용을 요구하며, 없으면 답변을 보류합니다. AI는 의료진 진단을 임의로 갱신하지 않습니다.”</a:t>
             </a:r>
           </a:p>
         </p:txBody>
@@ -1357,7 +1357,7 @@
           <a:p/>
           <a:p>
             <a:r>
-              <a:t>“이제 실제 Luna 대화 C입니다. 한의사가 기록한 진단·평가와 23시 전 취침 지침을 바탕으로 Hanui가 먼저 취침 시각을 물었습니다. 제가 ‘어제 새벽 1시에 잤어. 어제 5시간 잤어’라고 답하겠습니다.” **C 화면에서 전송 후 약 20초 기다린다.** “환자 발언의 날짜와 시각을 확인해 취침 지침과의 차이를 기록하고, 오늘 피곤함이나 불편함을 이어 묻습니다. 오른쪽 PDF 캡처는 같은 기능의 별도 합성 데모 A입니다.”</a:t>
+              <a:t>“앱 안의 실제 Luna 대화 C입니다. 한의사 진단·지침을 바탕으로 Hanui가 이미 먼저 말을 걸었습니다. 제가 ‘어제 새벽 1시에 잤어. 어제 5시간 잤어’라고 답하겠습니다.” **C 화면에서 전송 후 약 20초 기다린다.** “발언의 날짜·시각을 지침과 비교해 기록하고 오늘의 불편함을 이어 묻습니다. 푸시나 문자 연락은 아닙니다. PDF는 별도 합성 데모 A입니다.” 시연 C: `http://127.0.0.1:8765/?session=a63cdbff74c6445a91a348fb03da48ed`</a:t>
             </a:r>
           </a:p>
         </p:txBody>
@@ -4838,7 +4838,7 @@
               </a:defRPr>
             </a:pPr>
             <a:r>
-              <a:t>한의사 진단·지침에서 첫 질문, 답변, 내원 리포트까지</a:t>
+              <a:t>한의사 지침부터 앱 내 선제 대화, 다음 방문 관리까지</a:t>
             </a:r>
           </a:p>
         </p:txBody>
@@ -5258,7 +5258,7 @@
         </p:blipFill>
         <p:spPr>
           <a:xfrm>
-            <a:off x="5696712" y="1847088"/>
+            <a:off x="5696712" y="2023684"/>
             <a:ext cx="5669280" cy="3761607"/>
           </a:xfrm>
           <a:prstGeom prst="rect">
@@ -6786,7 +6786,7 @@
               </a:defRPr>
             </a:pPr>
             <a:r>
-              <a:t>단위 테스트 76개 통과</a:t>
+              <a:t>단위 테스트 80개 통과</a:t>
             </a:r>
           </a:p>
           <a:p>
@@ -7204,7 +7204,7 @@
               </a:defRPr>
             </a:pPr>
             <a:r>
-              <a:t>Codex가 구현하고, 원문과 작동을 대조했다</a:t>
+              <a:t>역할을 나눠 만들고, 원문과 작동을 대조했다</a:t>
             </a:r>
           </a:p>
         </p:txBody>
@@ -7409,7 +7409,7 @@
               </a:defRPr>
             </a:pPr>
             <a:r>
-              <a:t>Codex: 서버·DB·UI·검색·테스트·자료 정리</a:t>
+              <a:t>서브 에이전트로 고전 문헌탐색</a:t>
             </a:r>
           </a:p>
         </p:txBody>
@@ -7493,7 +7493,7 @@
               </a:defRPr>
             </a:pPr>
             <a:r>
-              <a:t>Codex 검토: 원전 판본·인용 위치·생활 판정·화면 동작</a:t>
+              <a:t>메인: UI·백엔드 구현, 단위·화면·Luna 연동 검증</a:t>
             </a:r>
           </a:p>
         </p:txBody>
@@ -7577,7 +7577,7 @@
               </a:defRPr>
             </a:pPr>
             <a:r>
-              <a:t>사용자 피드백: 핵심 집중, 대화창 확대, 해석 우선 표시</a:t>
+              <a:t>원전 판본·인용 위치·환자 원문·날짜·수치 재검증</a:t>
             </a:r>
           </a:p>
         </p:txBody>
@@ -7769,7 +7769,7 @@
               </a:defRPr>
             </a:pPr>
             <a:r>
-              <a:t>HANUI RELAY  /  도입 가능성</a:t>
+              <a:t>HANUI RELAY  /  확장 계획</a:t>
             </a:r>
           </a:p>
         </p:txBody>
@@ -7808,7 +7808,7 @@
               </a:defRPr>
             </a:pPr>
             <a:r>
-              <a:t>다음 만남의 준비 시간을 줄일 수 있는지 검증한다</a:t>
+              <a:t>한의학에서 시작해 현대의학 관리로 넓힌다</a:t>
             </a:r>
           </a:p>
         </p:txBody>
@@ -8265,7 +8265,7 @@
               </a:defRPr>
             </a:pPr>
             <a:r>
-              <a:t>지침 변경·재방문마다 기록 연결 · 가격과 효과는 아직 미측정</a:t>
+              <a:t>공통 구조 유지 · 다른 분야는 검증된 자료·전문가 지침으로 교체</a:t>
             </a:r>
           </a:p>
         </p:txBody>
@@ -8593,8 +8593,8 @@
         </p:nvSpPr>
         <p:spPr>
           <a:xfrm>
-            <a:off x="612648" y="1938528"/>
-            <a:ext cx="64008" cy="2880360"/>
+            <a:off x="612648" y="2514600"/>
+            <a:ext cx="64008" cy="1728216"/>
           </a:xfrm>
           <a:prstGeom prst="rect">
             <a:avLst/>
@@ -8761,8 +8761,8 @@
         </p:nvSpPr>
         <p:spPr>
           <a:xfrm>
-            <a:off x="6199632" y="1938528"/>
-            <a:ext cx="64008" cy="2880360"/>
+            <a:off x="6199632" y="2514600"/>
+            <a:ext cx="64008" cy="1728216"/>
           </a:xfrm>
           <a:prstGeom prst="rect">
             <a:avLst/>
@@ -9055,7 +9055,7 @@
               </a:defRPr>
             </a:pPr>
             <a:r>
-              <a:t>생활 지침과 한자 원전의 정보 장벽이 함께 있다</a:t>
+              <a:t>고문헌 원전의 저작권 만료는 출처 있는 활용의 출발점</a:t>
             </a:r>
           </a:p>
         </p:txBody>
@@ -9260,7 +9260,7 @@
               </a:defRPr>
             </a:pPr>
             <a:r>
-              <a:t>수면·식사·활동 등 일상에서 이어지는 지침</a:t>
+              <a:t>저작권이 만료된 고문헌 원전을 활용 가능</a:t>
             </a:r>
           </a:p>
         </p:txBody>
@@ -9344,7 +9344,7 @@
               </a:defRPr>
             </a:pPr>
             <a:r>
-              <a:t>고문헌 원문을 환자가 바로 읽기 어려움</a:t>
+              <a:t>한자 원문의 해석·출처 장벽을 낮출 필요</a:t>
             </a:r>
           </a:p>
         </p:txBody>
@@ -9428,7 +9428,7 @@
               </a:defRPr>
             </a:pPr>
             <a:r>
-              <a:t>환자 설명과 한의사 확인 사이에 출처가 필요</a:t>
+              <a:t>생활 지침과 환자·한의사 재방문 접점</a:t>
             </a:r>
           </a:p>
         </p:txBody>
@@ -9442,7 +9442,7 @@
         <p:spPr>
           <a:xfrm>
             <a:off x="768096" y="5340096"/>
-            <a:ext cx="8412480" cy="393192"/>
+            <a:ext cx="9372600" cy="393192"/>
           </a:xfrm>
           <a:prstGeom prst="roundRect">
             <a:avLst>
@@ -9487,7 +9487,7 @@
         <p:spPr>
           <a:xfrm>
             <a:off x="886968" y="5394959"/>
-            <a:ext cx="8183879" cy="274320"/>
+            <a:ext cx="9144000" cy="274320"/>
           </a:xfrm>
           <a:prstGeom prst="rect">
             <a:avLst/>
@@ -9512,7 +9512,7 @@
               </a:defRPr>
             </a:pPr>
             <a:r>
-              <a:t>목표: 해석과 기록 접근성 / 진단·처방·효능 주장 아님</a:t>
+              <a:t>현대 번역·편집본은 별도 권리 / 공개 전사본도 이용 조건 준수</a:t>
             </a:r>
           </a:p>
         </p:txBody>
@@ -11014,7 +11014,7 @@
               </a:defRPr>
             </a:pPr>
             <a:r>
-              <a:t>DB 본문 인용 문자열·위치 확인</a:t>
+              <a:t>고문헌 인용 문자열·위치 확인</a:t>
             </a:r>
           </a:p>
           <a:p>
@@ -11030,7 +11030,7 @@
               </a:defRPr>
             </a:pPr>
             <a:r>
-              <a:t>세션 소유권·일정 상태 검증</a:t>
+              <a:t>원문 인용 없으면 답변 보류</a:t>
             </a:r>
           </a:p>
         </p:txBody>
@@ -11765,7 +11765,7 @@
               </a:defRPr>
             </a:pPr>
             <a:r>
-              <a:t>한의사 진단·지침에서 첫 확인 질문이 시작된다</a:t>
+              <a:t>앱 안에서 Hanui가 먼저 말을 건다</a:t>
             </a:r>
           </a:p>
         </p:txBody>
@@ -11954,8 +11954,8 @@
         </p:blipFill>
         <p:spPr>
           <a:xfrm>
-            <a:off x="5623560" y="1865376"/>
-            <a:ext cx="5760720" cy="3137025"/>
+            <a:off x="5852160" y="2204428"/>
+            <a:ext cx="5303519" cy="2888055"/>
           </a:xfrm>
           <a:prstGeom prst="rect">
             <a:avLst/>
@@ -12223,7 +12223,7 @@
         <p:spPr>
           <a:xfrm>
             <a:off x="713232" y="5971032"/>
-            <a:ext cx="4663440" cy="274320"/>
+            <a:ext cx="7315200" cy="274320"/>
           </a:xfrm>
           <a:prstGeom prst="rect">
             <a:avLst/>
@@ -12248,7 +12248,7 @@
               </a:defRPr>
             </a:pPr>
             <a:r>
-              <a:t>합성 환자·지침 예시</a:t>
+              <a:t>합성 환자·지침 예시 / 푸시·문자 연락 아님</a:t>
             </a:r>
           </a:p>
         </p:txBody>
@@ -12584,7 +12584,7 @@
         </p:blipFill>
         <p:spPr>
           <a:xfrm>
-            <a:off x="5669280" y="2057400"/>
+            <a:off x="5669280" y="2388931"/>
             <a:ext cx="5705856" cy="2583056"/>
           </a:xfrm>
           <a:prstGeom prst="rect">
@@ -13214,8 +13214,8 @@
         </p:blipFill>
         <p:spPr>
           <a:xfrm>
-            <a:off x="5687567" y="1828800"/>
-            <a:ext cx="5687568" cy="3719831"/>
+            <a:off x="5916167" y="2184939"/>
+            <a:ext cx="5230368" cy="3420809"/>
           </a:xfrm>
           <a:prstGeom prst="rect">
             <a:avLst/>

</xml_diff>

<commit_message>
Add proactive coaching, adherence capture, and DB conversation to 10-minute deck
</commit_message>
<xml_diff>
--- a/presentations/Hanui-Relay-10min.pptx
+++ b/presentations/Hanui-Relay-10min.pptx
@@ -1357,7 +1357,7 @@
           <a:p/>
           <a:p>
             <a:r>
-              <a:t>“앱 안의 실제 Luna 대화 C입니다. 한의사 진단·지침을 바탕으로 Hanui가 이미 먼저 말을 걸었습니다. 제가 ‘어제 새벽 1시에 잤어. 어제 5시간 잤어’라고 답하겠습니다.” **C 화면에서 전송 후 약 20초 기다린다.** “발언의 날짜·시각을 지침과 비교해 기록하고 오늘의 불편함을 이어 묻습니다. 푸시나 문자 연락은 아닙니다. PDF는 별도 합성 데모 A입니다.” 시연 C: `http://127.0.0.1:8765/?session=a63cdbff74c6445a91a348fb03da48ed`</a:t>
+              <a:t>“이것은 한의사 진단과 생활 지침을 바탕으로 에이전트가 먼저 묻는 **발표용 개념 화면**입니다. ‘오늘 점심 후 10분 산책하셨나요? 의사 선생님의 진단에 따른 생활 지침에 있었어요.’ 환자는 예 또는 아니요로 답하고, 답변은 날짜별 실천 기록과 다음 질문으로 이어집니다. 현재 앱은 먼저 질문하는 대화를 구현했지만 이 예/아니오 버튼은 구현된 UI가 아닙니다. 실제로는 대화 입력으로 답합니다.”</a:t>
             </a:r>
           </a:p>
         </p:txBody>
@@ -1433,7 +1433,7 @@
           <a:p/>
           <a:p>
             <a:r>
-              <a:t>“이제 별도로 준비한 합성 대화 A에서 자료 검색을 보겠습니다. 실제 서비스에서는 모델이 검색어를 정하고 서버가 DB의 원문·독해·메타데이터를 전문 검색합니다. 결과 카드에서는 한국어 해석을 먼저 읽고, 펼치면 원문·장절·문자 위치를 확인합니다. 인용 문자열이 DB 본문에 없으면 저장하지 않습니다. 환자 대화는 이전 기록을 이어갑니다.” 화면: A 대화·출처 카드.</a:t>
+              <a:t>“질문 형식은 생활 지침 확인에만 묶이지 않습니다. 한의학 DB를 바탕으로 ‘생활 리듬에 대해 고문헌은 어떻게 설명해?’처럼 자유롭게 물을 수 있습니다. 발표용 답변 예시는 ‘동의보감에는 음식과 일상생활에 일정한 절도가 있다는 옛 설명이 있어요. 생활 관리는 담당 의료진의 지침을 기준으로 함께 살펴봐요’입니다. 실제 수록 원문 ‘飮食有節，起居有常’의 한국어 해석, 동의보감 장절과 DB 문자 위치 85–94를 화면에서 확인합니다. 역사 자료를 임상 효과로 설명하지 않습니다.”</a:t>
             </a:r>
           </a:p>
         </p:txBody>
@@ -1509,7 +1509,7 @@
           <a:p/>
           <a:p>
             <a:r>
-              <a:t>“이 화면은 방금 실제로 답한 C와 **별개의 합성 대화 A**에서 미리 준비한 14일 내원 리포트입니다. 8일에 기록이 있고, 그중 6일이 지침을 준수해 75%입니다. 기록 없는 6일은 미준수로 세지 않습니다. 수면과 식사 추이, 불편감도 환자가 말한 날짜와 원문 문장에 연결됩니다. 근거를 누르면 메시지의 인용 위치가 보이고 다시 대화로 돌아갑니다. PDF에서도 그 링크를 사용할 수 있습니다. 이 비율은 기능 예시이지 임상 결과가 아닙니다.” 화면: 비율·빈 날·근거.</a:t>
+              <a:t>“이 기록 화면은 별도 합성 대화 A의 14일 예시입니다. 한의사의 네 생활 지침에 대해 기록된 8일 가운데 6일이 준수되어 이행률은 **6/8, 75%**입니다. 기록 없는 6일은 미준수로 세지 않습니다. 숫자만 보이지 않고 지침 원문, 환자 발언 날짜와 근거로 돌아갈 수 있습니다. 이 화면은 실제 환자의 임상 효과가 아니라 지침과 일상 기록이 다음 방문까지 어떻게 연결되는지 보여주는 합성 기능 예시입니다.”</a:t>
             </a:r>
           </a:p>
         </p:txBody>
@@ -11726,7 +11726,7 @@
               </a:defRPr>
             </a:pPr>
             <a:r>
-              <a:t>HANUI RELAY  /  데모 ①</a:t>
+              <a:t>HANUI RELAY  /  발표용 개념 예시</a:t>
             </a:r>
           </a:p>
         </p:txBody>
@@ -11765,7 +11765,7 @@
               </a:defRPr>
             </a:pPr>
             <a:r>
-              <a:t>앱 안에서 Hanui가 먼저 말을 건다</a:t>
+              <a:t>에이전트가 먼저 예·아니오로 확인한다</a:t>
             </a:r>
           </a:p>
         </p:txBody>
@@ -11899,8 +11899,260 @@
         </p:nvSpPr>
         <p:spPr>
           <a:xfrm>
-            <a:off x="5586984" y="1828800"/>
-            <a:ext cx="5833872" cy="3639312"/>
+            <a:off x="685800" y="2212848"/>
+            <a:ext cx="109728" cy="109728"/>
+          </a:xfrm>
+          <a:prstGeom prst="roundRect">
+            <a:avLst>
+              <a:gd name="adj" fmla="val 12000"/>
+            </a:avLst>
+          </a:prstGeom>
+          <a:solidFill>
+            <a:srgbClr val="13533D"/>
+          </a:solidFill>
+          <a:ln>
+            <a:noFill/>
+          </a:ln>
+        </p:spPr>
+        <p:style>
+          <a:lnRef idx="1">
+            <a:schemeClr val="accent1"/>
+          </a:lnRef>
+          <a:fillRef idx="3">
+            <a:schemeClr val="accent1"/>
+          </a:fillRef>
+          <a:effectRef idx="2">
+            <a:schemeClr val="accent1"/>
+          </a:effectRef>
+          <a:fontRef idx="minor">
+            <a:schemeClr val="lt1"/>
+          </a:fontRef>
+        </p:style>
+        <p:txBody>
+          <a:bodyPr rtlCol="0" anchor="ctr"/>
+          <a:lstStyle/>
+          <a:p>
+            <a:pPr algn="ctr"/>
+          </a:p>
+        </p:txBody>
+      </p:sp>
+      <p:sp>
+        <p:nvSpPr>
+          <p:cNvPr id="9" name="TextBox 8"/>
+          <p:cNvSpPr txBox="1"/>
+          <p:nvPr/>
+        </p:nvSpPr>
+        <p:spPr>
+          <a:xfrm>
+            <a:off x="960120" y="2130552"/>
+            <a:ext cx="4572000" cy="640080"/>
+          </a:xfrm>
+          <a:prstGeom prst="rect">
+            <a:avLst/>
+          </a:prstGeom>
+          <a:noFill/>
+        </p:spPr>
+        <p:txBody>
+          <a:bodyPr wrap="square" lIns="18288" rIns="18288" tIns="9144" bIns="9144">
+            <a:spAutoFit/>
+          </a:bodyPr>
+          <a:lstStyle/>
+          <a:p>
+            <a:pPr>
+              <a:spcAft>
+                <a:spcPts val="1000"/>
+              </a:spcAft>
+              <a:defRPr sz="1900" b="0">
+                <a:solidFill>
+                  <a:srgbClr val="1C2A24"/>
+                </a:solidFill>
+                <a:latin typeface="맑은 고딕"/>
+              </a:defRPr>
+            </a:pPr>
+            <a:r>
+              <a:t>한의사 진단·생활 지침을 맥락으로</a:t>
+            </a:r>
+          </a:p>
+        </p:txBody>
+      </p:sp>
+      <p:sp>
+        <p:nvSpPr>
+          <p:cNvPr id="10" name="Rounded Rectangle 9"/>
+          <p:cNvSpPr/>
+          <p:nvPr/>
+        </p:nvSpPr>
+        <p:spPr>
+          <a:xfrm>
+            <a:off x="685800" y="3209544"/>
+            <a:ext cx="109728" cy="109728"/>
+          </a:xfrm>
+          <a:prstGeom prst="roundRect">
+            <a:avLst>
+              <a:gd name="adj" fmla="val 12000"/>
+            </a:avLst>
+          </a:prstGeom>
+          <a:solidFill>
+            <a:srgbClr val="13533D"/>
+          </a:solidFill>
+          <a:ln>
+            <a:noFill/>
+          </a:ln>
+        </p:spPr>
+        <p:style>
+          <a:lnRef idx="1">
+            <a:schemeClr val="accent1"/>
+          </a:lnRef>
+          <a:fillRef idx="3">
+            <a:schemeClr val="accent1"/>
+          </a:fillRef>
+          <a:effectRef idx="2">
+            <a:schemeClr val="accent1"/>
+          </a:effectRef>
+          <a:fontRef idx="minor">
+            <a:schemeClr val="lt1"/>
+          </a:fontRef>
+        </p:style>
+        <p:txBody>
+          <a:bodyPr rtlCol="0" anchor="ctr"/>
+          <a:lstStyle/>
+          <a:p>
+            <a:pPr algn="ctr"/>
+          </a:p>
+        </p:txBody>
+      </p:sp>
+      <p:sp>
+        <p:nvSpPr>
+          <p:cNvPr id="11" name="TextBox 10"/>
+          <p:cNvSpPr txBox="1"/>
+          <p:nvPr/>
+        </p:nvSpPr>
+        <p:spPr>
+          <a:xfrm>
+            <a:off x="960120" y="3127248"/>
+            <a:ext cx="4572000" cy="640080"/>
+          </a:xfrm>
+          <a:prstGeom prst="rect">
+            <a:avLst/>
+          </a:prstGeom>
+          <a:noFill/>
+        </p:spPr>
+        <p:txBody>
+          <a:bodyPr wrap="square" lIns="18288" rIns="18288" tIns="9144" bIns="9144">
+            <a:spAutoFit/>
+          </a:bodyPr>
+          <a:lstStyle/>
+          <a:p>
+            <a:pPr>
+              <a:spcAft>
+                <a:spcPts val="1000"/>
+              </a:spcAft>
+              <a:defRPr sz="1900" b="0">
+                <a:solidFill>
+                  <a:srgbClr val="1C2A24"/>
+                </a:solidFill>
+                <a:latin typeface="맑은 고딕"/>
+              </a:defRPr>
+            </a:pPr>
+            <a:r>
+              <a:t>Hanui가 오늘의 실천 여부를 먼저 질문</a:t>
+            </a:r>
+          </a:p>
+        </p:txBody>
+      </p:sp>
+      <p:sp>
+        <p:nvSpPr>
+          <p:cNvPr id="12" name="Rounded Rectangle 11"/>
+          <p:cNvSpPr/>
+          <p:nvPr/>
+        </p:nvSpPr>
+        <p:spPr>
+          <a:xfrm>
+            <a:off x="685800" y="4206240"/>
+            <a:ext cx="109728" cy="109728"/>
+          </a:xfrm>
+          <a:prstGeom prst="roundRect">
+            <a:avLst>
+              <a:gd name="adj" fmla="val 12000"/>
+            </a:avLst>
+          </a:prstGeom>
+          <a:solidFill>
+            <a:srgbClr val="13533D"/>
+          </a:solidFill>
+          <a:ln>
+            <a:noFill/>
+          </a:ln>
+        </p:spPr>
+        <p:style>
+          <a:lnRef idx="1">
+            <a:schemeClr val="accent1"/>
+          </a:lnRef>
+          <a:fillRef idx="3">
+            <a:schemeClr val="accent1"/>
+          </a:fillRef>
+          <a:effectRef idx="2">
+            <a:schemeClr val="accent1"/>
+          </a:effectRef>
+          <a:fontRef idx="minor">
+            <a:schemeClr val="lt1"/>
+          </a:fontRef>
+        </p:style>
+        <p:txBody>
+          <a:bodyPr rtlCol="0" anchor="ctr"/>
+          <a:lstStyle/>
+          <a:p>
+            <a:pPr algn="ctr"/>
+          </a:p>
+        </p:txBody>
+      </p:sp>
+      <p:sp>
+        <p:nvSpPr>
+          <p:cNvPr id="13" name="TextBox 12"/>
+          <p:cNvSpPr txBox="1"/>
+          <p:nvPr/>
+        </p:nvSpPr>
+        <p:spPr>
+          <a:xfrm>
+            <a:off x="960120" y="4123944"/>
+            <a:ext cx="4572000" cy="640080"/>
+          </a:xfrm>
+          <a:prstGeom prst="rect">
+            <a:avLst/>
+          </a:prstGeom>
+          <a:noFill/>
+        </p:spPr>
+        <p:txBody>
+          <a:bodyPr wrap="square" lIns="18288" rIns="18288" tIns="9144" bIns="9144">
+            <a:spAutoFit/>
+          </a:bodyPr>
+          <a:lstStyle/>
+          <a:p>
+            <a:pPr>
+              <a:spcAft>
+                <a:spcPts val="1000"/>
+              </a:spcAft>
+              <a:defRPr sz="1900" b="0">
+                <a:solidFill>
+                  <a:srgbClr val="1C2A24"/>
+                </a:solidFill>
+                <a:latin typeface="맑은 고딕"/>
+              </a:defRPr>
+            </a:pPr>
+            <a:r>
+              <a:t>응답은 날짜별 기록·다음 질문으로 연결</a:t>
+            </a:r>
+          </a:p>
+        </p:txBody>
+      </p:sp>
+      <p:sp>
+        <p:nvSpPr>
+          <p:cNvPr id="14" name="Rounded Rectangle 13"/>
+          <p:cNvSpPr/>
+          <p:nvPr/>
+        </p:nvSpPr>
+        <p:spPr>
+          <a:xfrm>
+            <a:off x="5641848" y="1847088"/>
+            <a:ext cx="5705856" cy="3621024"/>
           </a:xfrm>
           <a:prstGeom prst="roundRect">
             <a:avLst>
@@ -11938,40 +12190,16 @@
           </a:p>
         </p:txBody>
       </p:sp>
-      <p:pic>
-        <p:nvPicPr>
-          <p:cNvPr id="9" name="Picture 8" descr="opening-sequence-v2-crop-0-550.png"/>
-          <p:cNvPicPr>
-            <a:picLocks noChangeAspect="1"/>
-          </p:cNvPicPr>
-          <p:nvPr/>
-        </p:nvPicPr>
-        <p:blipFill>
-          <a:blip r:embed="rId2"/>
-          <a:stretch>
-            <a:fillRect/>
-          </a:stretch>
-        </p:blipFill>
-        <p:spPr>
-          <a:xfrm>
-            <a:off x="5852160" y="2204428"/>
-            <a:ext cx="5303519" cy="2888055"/>
-          </a:xfrm>
-          <a:prstGeom prst="rect">
-            <a:avLst/>
-          </a:prstGeom>
-        </p:spPr>
-      </p:pic>
-      <p:sp>
-        <p:nvSpPr>
-          <p:cNvPr id="10" name="Rounded Rectangle 9"/>
+      <p:sp>
+        <p:nvSpPr>
+          <p:cNvPr id="15" name="Rounded Rectangle 14"/>
           <p:cNvSpPr/>
           <p:nvPr/>
         </p:nvSpPr>
         <p:spPr>
           <a:xfrm>
-            <a:off x="685800" y="2212848"/>
-            <a:ext cx="109728" cy="109728"/>
+            <a:off x="5934456" y="2112264"/>
+            <a:ext cx="5010912" cy="393192"/>
           </a:xfrm>
           <a:prstGeom prst="roundRect">
             <a:avLst>
@@ -11979,7 +12207,7 @@
             </a:avLst>
           </a:prstGeom>
           <a:solidFill>
-            <a:srgbClr val="13533D"/>
+            <a:srgbClr val="E0F0E8"/>
           </a:solidFill>
           <a:ln>
             <a:noFill/>
@@ -12009,14 +12237,14 @@
       </p:sp>
       <p:sp>
         <p:nvSpPr>
-          <p:cNvPr id="11" name="TextBox 10"/>
+          <p:cNvPr id="16" name="TextBox 15"/>
           <p:cNvSpPr txBox="1"/>
           <p:nvPr/>
         </p:nvSpPr>
         <p:spPr>
           <a:xfrm>
-            <a:off x="960120" y="2130552"/>
-            <a:ext cx="4572000" cy="640080"/>
+            <a:off x="6053328" y="2167128"/>
+            <a:ext cx="4782312" cy="274320"/>
           </a:xfrm>
           <a:prstGeom prst="rect">
             <a:avLst/>
@@ -12033,7 +12261,85 @@
               <a:spcAft>
                 <a:spcPts val="1000"/>
               </a:spcAft>
-              <a:defRPr sz="1900" b="0">
+              <a:defRPr sz="1300" b="1">
+                <a:solidFill>
+                  <a:srgbClr val="13533D"/>
+                </a:solidFill>
+                <a:latin typeface="맑은 고딕"/>
+              </a:defRPr>
+            </a:pPr>
+            <a:r>
+              <a:t>의료진 지침을 기억하고 먼저 확인</a:t>
+            </a:r>
+          </a:p>
+        </p:txBody>
+      </p:sp>
+      <p:sp>
+        <p:nvSpPr>
+          <p:cNvPr id="17" name="TextBox 16"/>
+          <p:cNvSpPr txBox="1"/>
+          <p:nvPr/>
+        </p:nvSpPr>
+        <p:spPr>
+          <a:xfrm>
+            <a:off x="5961888" y="2834640"/>
+            <a:ext cx="5029200" cy="713232"/>
+          </a:xfrm>
+          <a:prstGeom prst="rect">
+            <a:avLst/>
+          </a:prstGeom>
+          <a:noFill/>
+        </p:spPr>
+        <p:txBody>
+          <a:bodyPr wrap="square" lIns="18288" rIns="18288" tIns="9144" bIns="9144">
+            <a:spAutoFit/>
+          </a:bodyPr>
+          <a:lstStyle/>
+          <a:p>
+            <a:pPr>
+              <a:spcAft>
+                <a:spcPts val="1000"/>
+              </a:spcAft>
+              <a:defRPr sz="2300" b="1">
+                <a:solidFill>
+                  <a:srgbClr val="13533D"/>
+                </a:solidFill>
+                <a:latin typeface="맑은 고딕"/>
+              </a:defRPr>
+            </a:pPr>
+            <a:r>
+              <a:t>오늘 점심 후 10분 산책하셨나요?</a:t>
+            </a:r>
+          </a:p>
+        </p:txBody>
+      </p:sp>
+      <p:sp>
+        <p:nvSpPr>
+          <p:cNvPr id="18" name="TextBox 17"/>
+          <p:cNvSpPr txBox="1"/>
+          <p:nvPr/>
+        </p:nvSpPr>
+        <p:spPr>
+          <a:xfrm>
+            <a:off x="5961888" y="3675887"/>
+            <a:ext cx="5010912" cy="676656"/>
+          </a:xfrm>
+          <a:prstGeom prst="rect">
+            <a:avLst/>
+          </a:prstGeom>
+          <a:noFill/>
+        </p:spPr>
+        <p:txBody>
+          <a:bodyPr wrap="square" lIns="18288" rIns="18288" tIns="9144" bIns="9144">
+            <a:spAutoFit/>
+          </a:bodyPr>
+          <a:lstStyle/>
+          <a:p>
+            <a:pPr>
+              <a:spcAft>
+                <a:spcPts val="1000"/>
+              </a:spcAft>
+              <a:defRPr sz="1600" b="0">
                 <a:solidFill>
                   <a:srgbClr val="1C2A24"/>
                 </a:solidFill>
@@ -12041,21 +12347,21 @@
               </a:defRPr>
             </a:pPr>
             <a:r>
-              <a:t>한의사 진단·23시 전 취침 지침</a:t>
-            </a:r>
-          </a:p>
-        </p:txBody>
-      </p:sp>
-      <p:sp>
-        <p:nvSpPr>
-          <p:cNvPr id="12" name="Rounded Rectangle 11"/>
+              <a:t>의사 선생님의 진단에 따른 생활 지침에 있었어요.</a:t>
+            </a:r>
+          </a:p>
+        </p:txBody>
+      </p:sp>
+      <p:sp>
+        <p:nvSpPr>
+          <p:cNvPr id="19" name="Rounded Rectangle 18"/>
           <p:cNvSpPr/>
           <p:nvPr/>
         </p:nvSpPr>
         <p:spPr>
           <a:xfrm>
-            <a:off x="685800" y="3209544"/>
-            <a:ext cx="109728" cy="109728"/>
+            <a:off x="6446520" y="4645152"/>
+            <a:ext cx="1737360" cy="576072"/>
           </a:xfrm>
           <a:prstGeom prst="roundRect">
             <a:avLst>
@@ -12063,7 +12369,7 @@
             </a:avLst>
           </a:prstGeom>
           <a:solidFill>
-            <a:srgbClr val="13533D"/>
+            <a:srgbClr val="E0F0E8"/>
           </a:solidFill>
           <a:ln>
             <a:noFill/>
@@ -12093,14 +12399,14 @@
       </p:sp>
       <p:sp>
         <p:nvSpPr>
-          <p:cNvPr id="13" name="TextBox 12"/>
+          <p:cNvPr id="20" name="TextBox 19"/>
           <p:cNvSpPr txBox="1"/>
           <p:nvPr/>
         </p:nvSpPr>
         <p:spPr>
           <a:xfrm>
-            <a:off x="960120" y="3127248"/>
-            <a:ext cx="4572000" cy="640080"/>
+            <a:off x="6858000" y="4745736"/>
+            <a:ext cx="868680" cy="338328"/>
           </a:xfrm>
           <a:prstGeom prst="rect">
             <a:avLst/>
@@ -12117,29 +12423,29 @@
               <a:spcAft>
                 <a:spcPts val="1000"/>
               </a:spcAft>
-              <a:defRPr sz="1900" b="0">
-                <a:solidFill>
-                  <a:srgbClr val="1C2A24"/>
+              <a:defRPr sz="1900" b="1">
+                <a:solidFill>
+                  <a:srgbClr val="13533D"/>
                 </a:solidFill>
                 <a:latin typeface="맑은 고딕"/>
               </a:defRPr>
             </a:pPr>
             <a:r>
-              <a:t>Hanui: ‘어젯밤 몇 시에 주무셨어요?’</a:t>
-            </a:r>
-          </a:p>
-        </p:txBody>
-      </p:sp>
-      <p:sp>
-        <p:nvSpPr>
-          <p:cNvPr id="14" name="Rounded Rectangle 13"/>
+              <a:t>예</a:t>
+            </a:r>
+          </a:p>
+        </p:txBody>
+      </p:sp>
+      <p:sp>
+        <p:nvSpPr>
+          <p:cNvPr id="21" name="Rounded Rectangle 20"/>
           <p:cNvSpPr/>
           <p:nvPr/>
         </p:nvSpPr>
         <p:spPr>
           <a:xfrm>
-            <a:off x="685800" y="4206240"/>
-            <a:ext cx="109728" cy="109728"/>
+            <a:off x="8677656" y="4645152"/>
+            <a:ext cx="1737360" cy="576072"/>
           </a:xfrm>
           <a:prstGeom prst="roundRect">
             <a:avLst>
@@ -12147,7 +12453,7 @@
             </a:avLst>
           </a:prstGeom>
           <a:solidFill>
-            <a:srgbClr val="13533D"/>
+            <a:srgbClr val="E0F0E8"/>
           </a:solidFill>
           <a:ln>
             <a:noFill/>
@@ -12177,14 +12483,14 @@
       </p:sp>
       <p:sp>
         <p:nvSpPr>
-          <p:cNvPr id="15" name="TextBox 14"/>
+          <p:cNvPr id="22" name="TextBox 21"/>
           <p:cNvSpPr txBox="1"/>
           <p:nvPr/>
         </p:nvSpPr>
         <p:spPr>
           <a:xfrm>
-            <a:off x="960120" y="4123944"/>
-            <a:ext cx="4572000" cy="640080"/>
+            <a:off x="8924544" y="4745736"/>
+            <a:ext cx="1225296" cy="338328"/>
           </a:xfrm>
           <a:prstGeom prst="rect">
             <a:avLst/>
@@ -12201,29 +12507,29 @@
               <a:spcAft>
                 <a:spcPts val="1000"/>
               </a:spcAft>
-              <a:defRPr sz="1900" b="0">
-                <a:solidFill>
-                  <a:srgbClr val="1C2A24"/>
+              <a:defRPr sz="1900" b="1">
+                <a:solidFill>
+                  <a:srgbClr val="13533D"/>
                 </a:solidFill>
                 <a:latin typeface="맑은 고딕"/>
               </a:defRPr>
             </a:pPr>
             <a:r>
-              <a:t>‘새벽 1시·5시간’ → 기록·다음 질문</a:t>
-            </a:r>
-          </a:p>
-        </p:txBody>
-      </p:sp>
-      <p:sp>
-        <p:nvSpPr>
-          <p:cNvPr id="16" name="TextBox 15"/>
+              <a:t>아니요</a:t>
+            </a:r>
+          </a:p>
+        </p:txBody>
+      </p:sp>
+      <p:sp>
+        <p:nvSpPr>
+          <p:cNvPr id="23" name="TextBox 22"/>
           <p:cNvSpPr txBox="1"/>
           <p:nvPr/>
         </p:nvSpPr>
         <p:spPr>
           <a:xfrm>
             <a:off x="713232" y="5971032"/>
-            <a:ext cx="7315200" cy="274320"/>
+            <a:ext cx="10789920" cy="274320"/>
           </a:xfrm>
           <a:prstGeom prst="rect">
             <a:avLst/>
@@ -12248,7 +12554,7 @@
               </a:defRPr>
             </a:pPr>
             <a:r>
-              <a:t>합성 환자·지침 예시 / 푸시·문자 연락 아님</a:t>
+              <a:t>앱 내 선제 대화는 구현 · 예/아니오 버튼은 기획 화면</a:t>
             </a:r>
           </a:p>
         </p:txBody>
@@ -12356,7 +12662,7 @@
               </a:defRPr>
             </a:pPr>
             <a:r>
-              <a:t>HANUI RELAY  /  데모 ②</a:t>
+              <a:t>HANUI RELAY  /  발표용 대화 예시</a:t>
             </a:r>
           </a:p>
         </p:txBody>
@@ -12395,7 +12701,7 @@
               </a:defRPr>
             </a:pPr>
             <a:r>
-              <a:t>대화 중 고문헌을 찾아 원문 위치까지 확인</a:t>
+              <a:t>한의학 DB를 바탕으로 자유롭게 묻고 답한다</a:t>
             </a:r>
           </a:p>
         </p:txBody>
@@ -12529,8 +12835,8 @@
         </p:nvSpPr>
         <p:spPr>
           <a:xfrm>
-            <a:off x="5632704" y="2020824"/>
-            <a:ext cx="5779008" cy="3319272"/>
+            <a:off x="5632704" y="1810512"/>
+            <a:ext cx="5779008" cy="3950208"/>
           </a:xfrm>
           <a:prstGeom prst="roundRect">
             <a:avLst>
@@ -12570,7 +12876,7 @@
       </p:sp>
       <p:pic>
         <p:nvPicPr>
-          <p:cNvPr id="9" name="Picture 8" descr="chat-source-detail-crop-0-335.png"/>
+          <p:cNvPr id="9" name="Picture 8" descr="db-free-conversation-example-crop-0-1043.png"/>
           <p:cNvPicPr>
             <a:picLocks noChangeAspect="1"/>
           </p:cNvPicPr>
@@ -12584,8 +12890,8 @@
         </p:blipFill>
         <p:spPr>
           <a:xfrm>
-            <a:off x="5669280" y="2388931"/>
-            <a:ext cx="5705856" cy="2583056"/>
+            <a:off x="5797296" y="2168958"/>
+            <a:ext cx="5449824" cy="3233314"/>
           </a:xfrm>
           <a:prstGeom prst="rect">
             <a:avLst/>
@@ -12600,7 +12906,7 @@
         </p:nvSpPr>
         <p:spPr>
           <a:xfrm>
-            <a:off x="685800" y="2212848"/>
+            <a:off x="685800" y="2167127"/>
             <a:ext cx="109728" cy="109728"/>
           </a:xfrm>
           <a:prstGeom prst="roundRect">
@@ -12645,7 +12951,7 @@
         </p:nvSpPr>
         <p:spPr>
           <a:xfrm>
-            <a:off x="960120" y="2130552"/>
+            <a:off x="960120" y="2084831"/>
             <a:ext cx="4480560" cy="640080"/>
           </a:xfrm>
           <a:prstGeom prst="rect">
@@ -12663,7 +12969,7 @@
               <a:spcAft>
                 <a:spcPts val="1000"/>
               </a:spcAft>
-              <a:defRPr sz="1900" b="0">
+              <a:defRPr sz="1800" b="0">
                 <a:solidFill>
                   <a:srgbClr val="1C2A24"/>
                 </a:solidFill>
@@ -12671,7 +12977,7 @@
               </a:defRPr>
             </a:pPr>
             <a:r>
-              <a:t>Luna가 질문의 검색어 선택</a:t>
+              <a:t>Q  생활 리듬을 고문헌은 어떻게 설명할까?</a:t>
             </a:r>
           </a:p>
         </p:txBody>
@@ -12684,7 +12990,7 @@
         </p:nvSpPr>
         <p:spPr>
           <a:xfrm>
-            <a:off x="685800" y="3200400"/>
+            <a:off x="685800" y="3172968"/>
             <a:ext cx="109728" cy="109728"/>
           </a:xfrm>
           <a:prstGeom prst="roundRect">
@@ -12729,7 +13035,7 @@
         </p:nvSpPr>
         <p:spPr>
           <a:xfrm>
-            <a:off x="960120" y="3118104"/>
+            <a:off x="960120" y="3090672"/>
             <a:ext cx="4480560" cy="640080"/>
           </a:xfrm>
           <a:prstGeom prst="rect">
@@ -12747,7 +13053,7 @@
               <a:spcAft>
                 <a:spcPts val="1000"/>
               </a:spcAft>
-              <a:defRPr sz="1900" b="0">
+              <a:defRPr sz="1800" b="0">
                 <a:solidFill>
                   <a:srgbClr val="1C2A24"/>
                 </a:solidFill>
@@ -12755,7 +13061,7 @@
               </a:defRPr>
             </a:pPr>
             <a:r>
-              <a:t>SQLite 원문·독해 전문 검색</a:t>
+              <a:t>A  동의보감 원문을 한국어로 설명</a:t>
             </a:r>
           </a:p>
         </p:txBody>
@@ -12768,7 +13074,7 @@
         </p:nvSpPr>
         <p:spPr>
           <a:xfrm>
-            <a:off x="685800" y="4187952"/>
+            <a:off x="685800" y="4178808"/>
             <a:ext cx="109728" cy="109728"/>
           </a:xfrm>
           <a:prstGeom prst="roundRect">
@@ -12813,7 +13119,7 @@
         </p:nvSpPr>
         <p:spPr>
           <a:xfrm>
-            <a:off x="960120" y="4105656"/>
+            <a:off x="960120" y="4096512"/>
             <a:ext cx="4480560" cy="640080"/>
           </a:xfrm>
           <a:prstGeom prst="rect">
@@ -12831,7 +13137,7 @@
               <a:spcAft>
                 <a:spcPts val="1000"/>
               </a:spcAft>
-              <a:defRPr sz="1900" b="0">
+              <a:defRPr sz="1800" b="0">
                 <a:solidFill>
                   <a:srgbClr val="1C2A24"/>
                 </a:solidFill>
@@ -12839,7 +13145,7 @@
               </a:defRPr>
             </a:pPr>
             <a:r>
-              <a:t>원문 인용·장절·문자 위치 표시</a:t>
+              <a:t>원문·장절·문자 위치까지 확인</a:t>
             </a:r>
           </a:p>
         </p:txBody>
@@ -12853,7 +13159,7 @@
         <p:spPr>
           <a:xfrm>
             <a:off x="713232" y="5925312"/>
-            <a:ext cx="5029200" cy="329184"/>
+            <a:ext cx="8412480" cy="329184"/>
           </a:xfrm>
           <a:prstGeom prst="rect">
             <a:avLst/>
@@ -12878,7 +13184,7 @@
               </a:defRPr>
             </a:pPr>
             <a:r>
-              <a:t>역사 기록과 현대 임상 근거를 구분</a:t>
+              <a:t>역사 기록은 현재의 진단·처방 근거로 사용하지 않음</a:t>
             </a:r>
           </a:p>
         </p:txBody>
@@ -12986,7 +13292,7 @@
               </a:defRPr>
             </a:pPr>
             <a:r>
-              <a:t>HANUI RELAY  /  데모 ③</a:t>
+              <a:t>HANUI RELAY  /  기록 화면</a:t>
             </a:r>
           </a:p>
         </p:txBody>
@@ -13025,7 +13331,7 @@
               </a:defRPr>
             </a:pPr>
             <a:r>
-              <a:t>14일 리포트는 집계부터 문장까지 추적 가능</a:t>
+              <a:t>한의사 지침 이행 75%를 근거와 함께 본다</a:t>
             </a:r>
           </a:p>
         </p:txBody>
@@ -13200,7 +13506,7 @@
       </p:sp>
       <p:pic>
         <p:nvPicPr>
-          <p:cNvPr id="9" name="Picture 8" descr="report-evidence-detail-crop-0-690.png"/>
+          <p:cNvPr id="9" name="Picture 8" descr="clinician-adherence-records-crop-0-1182.png"/>
           <p:cNvPicPr>
             <a:picLocks noChangeAspect="1"/>
           </p:cNvPicPr>
@@ -13214,8 +13520,8 @@
         </p:blipFill>
         <p:spPr>
           <a:xfrm>
-            <a:off x="5916167" y="2184939"/>
-            <a:ext cx="5230368" cy="3420809"/>
+            <a:off x="6102575" y="2029968"/>
+            <a:ext cx="4857552" cy="3730751"/>
           </a:xfrm>
           <a:prstGeom prst="rect">
             <a:avLst/>

</xml_diff>

<commit_message>
Remove green left accent stripes from all presentation cards
</commit_message>
<xml_diff>
--- a/presentations/Hanui-Relay-10min.pptx
+++ b/presentations/Hanui-Relay-10min.pptx
@@ -6672,50 +6672,7 @@
       </p:sp>
       <p:sp>
         <p:nvSpPr>
-          <p:cNvPr id="9" name="Rectangle 8"/>
-          <p:cNvSpPr/>
-          <p:nvPr/>
-        </p:nvSpPr>
-        <p:spPr>
-          <a:xfrm>
-            <a:off x="621792" y="1837943"/>
-            <a:ext cx="64008" cy="3337560"/>
-          </a:xfrm>
-          <a:prstGeom prst="rect">
-            <a:avLst/>
-          </a:prstGeom>
-          <a:solidFill>
-            <a:srgbClr val="13533D"/>
-          </a:solidFill>
-          <a:ln>
-            <a:noFill/>
-          </a:ln>
-        </p:spPr>
-        <p:style>
-          <a:lnRef idx="1">
-            <a:schemeClr val="accent1"/>
-          </a:lnRef>
-          <a:fillRef idx="3">
-            <a:schemeClr val="accent1"/>
-          </a:fillRef>
-          <a:effectRef idx="2">
-            <a:schemeClr val="accent1"/>
-          </a:effectRef>
-          <a:fontRef idx="minor">
-            <a:schemeClr val="lt1"/>
-          </a:fontRef>
-        </p:style>
-        <p:txBody>
-          <a:bodyPr rtlCol="0" anchor="ctr"/>
-          <a:lstStyle/>
-          <a:p>
-            <a:pPr algn="ctr"/>
-          </a:p>
-        </p:txBody>
-      </p:sp>
-      <p:sp>
-        <p:nvSpPr>
-          <p:cNvPr id="10" name="TextBox 9"/>
+          <p:cNvPr id="9" name="TextBox 8"/>
           <p:cNvSpPr txBox="1"/>
           <p:nvPr/>
         </p:nvSpPr>
@@ -6754,7 +6711,7 @@
       </p:sp>
       <p:sp>
         <p:nvSpPr>
-          <p:cNvPr id="11" name="TextBox 10"/>
+          <p:cNvPr id="10" name="TextBox 9"/>
           <p:cNvSpPr txBox="1"/>
           <p:nvPr/>
         </p:nvSpPr>
@@ -6825,7 +6782,7 @@
       </p:sp>
       <p:sp>
         <p:nvSpPr>
-          <p:cNvPr id="12" name="Rounded Rectangle 11"/>
+          <p:cNvPr id="11" name="Rounded Rectangle 10"/>
           <p:cNvSpPr/>
           <p:nvPr/>
         </p:nvSpPr>
@@ -6872,50 +6829,7 @@
       </p:sp>
       <p:sp>
         <p:nvSpPr>
-          <p:cNvPr id="13" name="Rectangle 12"/>
-          <p:cNvSpPr/>
-          <p:nvPr/>
-        </p:nvSpPr>
-        <p:spPr>
-          <a:xfrm>
-            <a:off x="6190488" y="1837943"/>
-            <a:ext cx="64008" cy="3337560"/>
-          </a:xfrm>
-          <a:prstGeom prst="rect">
-            <a:avLst/>
-          </a:prstGeom>
-          <a:solidFill>
-            <a:srgbClr val="13533D"/>
-          </a:solidFill>
-          <a:ln>
-            <a:noFill/>
-          </a:ln>
-        </p:spPr>
-        <p:style>
-          <a:lnRef idx="1">
-            <a:schemeClr val="accent1"/>
-          </a:lnRef>
-          <a:fillRef idx="3">
-            <a:schemeClr val="accent1"/>
-          </a:fillRef>
-          <a:effectRef idx="2">
-            <a:schemeClr val="accent1"/>
-          </a:effectRef>
-          <a:fontRef idx="minor">
-            <a:schemeClr val="lt1"/>
-          </a:fontRef>
-        </p:style>
-        <p:txBody>
-          <a:bodyPr rtlCol="0" anchor="ctr"/>
-          <a:lstStyle/>
-          <a:p>
-            <a:pPr algn="ctr"/>
-          </a:p>
-        </p:txBody>
-      </p:sp>
-      <p:sp>
-        <p:nvSpPr>
-          <p:cNvPr id="14" name="TextBox 13"/>
+          <p:cNvPr id="12" name="TextBox 11"/>
           <p:cNvSpPr txBox="1"/>
           <p:nvPr/>
         </p:nvSpPr>
@@ -6954,7 +6868,7 @@
       </p:sp>
       <p:sp>
         <p:nvSpPr>
-          <p:cNvPr id="15" name="TextBox 14"/>
+          <p:cNvPr id="13" name="TextBox 12"/>
           <p:cNvSpPr txBox="1"/>
           <p:nvPr/>
         </p:nvSpPr>
@@ -7025,7 +6939,7 @@
       </p:sp>
       <p:sp>
         <p:nvSpPr>
-          <p:cNvPr id="16" name="TextBox 15"/>
+          <p:cNvPr id="14" name="TextBox 13"/>
           <p:cNvSpPr txBox="1"/>
           <p:nvPr/>
         </p:nvSpPr>
@@ -8587,50 +8501,7 @@
       </p:sp>
       <p:sp>
         <p:nvSpPr>
-          <p:cNvPr id="9" name="Rectangle 8"/>
-          <p:cNvSpPr/>
-          <p:nvPr/>
-        </p:nvSpPr>
-        <p:spPr>
-          <a:xfrm>
-            <a:off x="612648" y="2514600"/>
-            <a:ext cx="64008" cy="1728216"/>
-          </a:xfrm>
-          <a:prstGeom prst="rect">
-            <a:avLst/>
-          </a:prstGeom>
-          <a:solidFill>
-            <a:srgbClr val="13533D"/>
-          </a:solidFill>
-          <a:ln>
-            <a:noFill/>
-          </a:ln>
-        </p:spPr>
-        <p:style>
-          <a:lnRef idx="1">
-            <a:schemeClr val="accent1"/>
-          </a:lnRef>
-          <a:fillRef idx="3">
-            <a:schemeClr val="accent1"/>
-          </a:fillRef>
-          <a:effectRef idx="2">
-            <a:schemeClr val="accent1"/>
-          </a:effectRef>
-          <a:fontRef idx="minor">
-            <a:schemeClr val="lt1"/>
-          </a:fontRef>
-        </p:style>
-        <p:txBody>
-          <a:bodyPr rtlCol="0" anchor="ctr"/>
-          <a:lstStyle/>
-          <a:p>
-            <a:pPr algn="ctr"/>
-          </a:p>
-        </p:txBody>
-      </p:sp>
-      <p:sp>
-        <p:nvSpPr>
-          <p:cNvPr id="10" name="TextBox 9"/>
+          <p:cNvPr id="9" name="TextBox 8"/>
           <p:cNvSpPr txBox="1"/>
           <p:nvPr/>
         </p:nvSpPr>
@@ -8669,7 +8540,7 @@
       </p:sp>
       <p:sp>
         <p:nvSpPr>
-          <p:cNvPr id="11" name="TextBox 10"/>
+          <p:cNvPr id="10" name="TextBox 9"/>
           <p:cNvSpPr txBox="1"/>
           <p:nvPr/>
         </p:nvSpPr>
@@ -8708,7 +8579,7 @@
       </p:sp>
       <p:sp>
         <p:nvSpPr>
-          <p:cNvPr id="12" name="Rounded Rectangle 11"/>
+          <p:cNvPr id="11" name="Rounded Rectangle 10"/>
           <p:cNvSpPr/>
           <p:nvPr/>
         </p:nvSpPr>
@@ -8755,50 +8626,7 @@
       </p:sp>
       <p:sp>
         <p:nvSpPr>
-          <p:cNvPr id="13" name="Rectangle 12"/>
-          <p:cNvSpPr/>
-          <p:nvPr/>
-        </p:nvSpPr>
-        <p:spPr>
-          <a:xfrm>
-            <a:off x="6199632" y="2514600"/>
-            <a:ext cx="64008" cy="1728216"/>
-          </a:xfrm>
-          <a:prstGeom prst="rect">
-            <a:avLst/>
-          </a:prstGeom>
-          <a:solidFill>
-            <a:srgbClr val="13533D"/>
-          </a:solidFill>
-          <a:ln>
-            <a:noFill/>
-          </a:ln>
-        </p:spPr>
-        <p:style>
-          <a:lnRef idx="1">
-            <a:schemeClr val="accent1"/>
-          </a:lnRef>
-          <a:fillRef idx="3">
-            <a:schemeClr val="accent1"/>
-          </a:fillRef>
-          <a:effectRef idx="2">
-            <a:schemeClr val="accent1"/>
-          </a:effectRef>
-          <a:fontRef idx="minor">
-            <a:schemeClr val="lt1"/>
-          </a:fontRef>
-        </p:style>
-        <p:txBody>
-          <a:bodyPr rtlCol="0" anchor="ctr"/>
-          <a:lstStyle/>
-          <a:p>
-            <a:pPr algn="ctr"/>
-          </a:p>
-        </p:txBody>
-      </p:sp>
-      <p:sp>
-        <p:nvSpPr>
-          <p:cNvPr id="14" name="TextBox 13"/>
+          <p:cNvPr id="12" name="TextBox 11"/>
           <p:cNvSpPr txBox="1"/>
           <p:nvPr/>
         </p:nvSpPr>
@@ -8837,7 +8665,7 @@
       </p:sp>
       <p:sp>
         <p:nvSpPr>
-          <p:cNvPr id="15" name="TextBox 14"/>
+          <p:cNvPr id="13" name="TextBox 12"/>
           <p:cNvSpPr txBox="1"/>
           <p:nvPr/>
         </p:nvSpPr>
@@ -8876,7 +8704,7 @@
       </p:sp>
       <p:sp>
         <p:nvSpPr>
-          <p:cNvPr id="16" name="TextBox 15"/>
+          <p:cNvPr id="14" name="TextBox 13"/>
           <p:cNvSpPr txBox="1"/>
           <p:nvPr/>
         </p:nvSpPr>
@@ -10209,50 +10037,7 @@
       </p:sp>
       <p:sp>
         <p:nvSpPr>
-          <p:cNvPr id="18" name="Rectangle 17"/>
-          <p:cNvSpPr/>
-          <p:nvPr/>
-        </p:nvSpPr>
-        <p:spPr>
-          <a:xfrm>
-            <a:off x="9262872" y="2075688"/>
-            <a:ext cx="64008" cy="2542032"/>
-          </a:xfrm>
-          <a:prstGeom prst="rect">
-            <a:avLst/>
-          </a:prstGeom>
-          <a:solidFill>
-            <a:srgbClr val="13533D"/>
-          </a:solidFill>
-          <a:ln>
-            <a:noFill/>
-          </a:ln>
-        </p:spPr>
-        <p:style>
-          <a:lnRef idx="1">
-            <a:schemeClr val="accent1"/>
-          </a:lnRef>
-          <a:fillRef idx="3">
-            <a:schemeClr val="accent1"/>
-          </a:fillRef>
-          <a:effectRef idx="2">
-            <a:schemeClr val="accent1"/>
-          </a:effectRef>
-          <a:fontRef idx="minor">
-            <a:schemeClr val="lt1"/>
-          </a:fontRef>
-        </p:style>
-        <p:txBody>
-          <a:bodyPr rtlCol="0" anchor="ctr"/>
-          <a:lstStyle/>
-          <a:p>
-            <a:pPr algn="ctr"/>
-          </a:p>
-        </p:txBody>
-      </p:sp>
-      <p:sp>
-        <p:nvSpPr>
-          <p:cNvPr id="19" name="TextBox 18"/>
+          <p:cNvPr id="18" name="TextBox 17"/>
           <p:cNvSpPr txBox="1"/>
           <p:nvPr/>
         </p:nvSpPr>
@@ -10291,7 +10076,7 @@
       </p:sp>
       <p:sp>
         <p:nvSpPr>
-          <p:cNvPr id="20" name="TextBox 19"/>
+          <p:cNvPr id="19" name="TextBox 18"/>
           <p:cNvSpPr txBox="1"/>
           <p:nvPr/>
         </p:nvSpPr>
@@ -10330,7 +10115,7 @@
       </p:sp>
       <p:sp>
         <p:nvSpPr>
-          <p:cNvPr id="21" name="TextBox 20"/>
+          <p:cNvPr id="20" name="TextBox 19"/>
           <p:cNvSpPr txBox="1"/>
           <p:nvPr/>
         </p:nvSpPr>
@@ -10684,50 +10469,7 @@
       </p:sp>
       <p:sp>
         <p:nvSpPr>
-          <p:cNvPr id="9" name="Rectangle 8"/>
-          <p:cNvSpPr/>
-          <p:nvPr/>
-        </p:nvSpPr>
-        <p:spPr>
-          <a:xfrm>
-            <a:off x="621792" y="1865376"/>
-            <a:ext cx="64008" cy="3383280"/>
-          </a:xfrm>
-          <a:prstGeom prst="rect">
-            <a:avLst/>
-          </a:prstGeom>
-          <a:solidFill>
-            <a:srgbClr val="13533D"/>
-          </a:solidFill>
-          <a:ln>
-            <a:noFill/>
-          </a:ln>
-        </p:spPr>
-        <p:style>
-          <a:lnRef idx="1">
-            <a:schemeClr val="accent1"/>
-          </a:lnRef>
-          <a:fillRef idx="3">
-            <a:schemeClr val="accent1"/>
-          </a:fillRef>
-          <a:effectRef idx="2">
-            <a:schemeClr val="accent1"/>
-          </a:effectRef>
-          <a:fontRef idx="minor">
-            <a:schemeClr val="lt1"/>
-          </a:fontRef>
-        </p:style>
-        <p:txBody>
-          <a:bodyPr rtlCol="0" anchor="ctr"/>
-          <a:lstStyle/>
-          <a:p>
-            <a:pPr algn="ctr"/>
-          </a:p>
-        </p:txBody>
-      </p:sp>
-      <p:sp>
-        <p:nvSpPr>
-          <p:cNvPr id="10" name="TextBox 9"/>
+          <p:cNvPr id="9" name="TextBox 8"/>
           <p:cNvSpPr txBox="1"/>
           <p:nvPr/>
         </p:nvSpPr>
@@ -10766,7 +10508,7 @@
       </p:sp>
       <p:sp>
         <p:nvSpPr>
-          <p:cNvPr id="11" name="TextBox 10"/>
+          <p:cNvPr id="10" name="TextBox 9"/>
           <p:cNvSpPr txBox="1"/>
           <p:nvPr/>
         </p:nvSpPr>
@@ -10837,7 +10579,7 @@
       </p:sp>
       <p:sp>
         <p:nvSpPr>
-          <p:cNvPr id="12" name="Rounded Rectangle 11"/>
+          <p:cNvPr id="11" name="Rounded Rectangle 10"/>
           <p:cNvSpPr/>
           <p:nvPr/>
         </p:nvSpPr>
@@ -10884,50 +10626,7 @@
       </p:sp>
       <p:sp>
         <p:nvSpPr>
-          <p:cNvPr id="13" name="Rectangle 12"/>
-          <p:cNvSpPr/>
-          <p:nvPr/>
-        </p:nvSpPr>
-        <p:spPr>
-          <a:xfrm>
-            <a:off x="6199632" y="1865376"/>
-            <a:ext cx="64008" cy="3383280"/>
-          </a:xfrm>
-          <a:prstGeom prst="rect">
-            <a:avLst/>
-          </a:prstGeom>
-          <a:solidFill>
-            <a:srgbClr val="13533D"/>
-          </a:solidFill>
-          <a:ln>
-            <a:noFill/>
-          </a:ln>
-        </p:spPr>
-        <p:style>
-          <a:lnRef idx="1">
-            <a:schemeClr val="accent1"/>
-          </a:lnRef>
-          <a:fillRef idx="3">
-            <a:schemeClr val="accent1"/>
-          </a:fillRef>
-          <a:effectRef idx="2">
-            <a:schemeClr val="accent1"/>
-          </a:effectRef>
-          <a:fontRef idx="minor">
-            <a:schemeClr val="lt1"/>
-          </a:fontRef>
-        </p:style>
-        <p:txBody>
-          <a:bodyPr rtlCol="0" anchor="ctr"/>
-          <a:lstStyle/>
-          <a:p>
-            <a:pPr algn="ctr"/>
-          </a:p>
-        </p:txBody>
-      </p:sp>
-      <p:sp>
-        <p:nvSpPr>
-          <p:cNvPr id="14" name="TextBox 13"/>
+          <p:cNvPr id="12" name="TextBox 11"/>
           <p:cNvSpPr txBox="1"/>
           <p:nvPr/>
         </p:nvSpPr>
@@ -10966,7 +10665,7 @@
       </p:sp>
       <p:sp>
         <p:nvSpPr>
-          <p:cNvPr id="15" name="TextBox 14"/>
+          <p:cNvPr id="13" name="TextBox 12"/>
           <p:cNvSpPr txBox="1"/>
           <p:nvPr/>
         </p:nvSpPr>
@@ -11037,7 +10736,7 @@
       </p:sp>
       <p:sp>
         <p:nvSpPr>
-          <p:cNvPr id="16" name="TextBox 15"/>
+          <p:cNvPr id="14" name="TextBox 13"/>
           <p:cNvSpPr txBox="1"/>
           <p:nvPr/>
         </p:nvSpPr>

</xml_diff>

<commit_message>
Unify agent wording and yes-no coaching across both presentation decks
</commit_message>
<xml_diff>
--- a/presentations/Hanui-Relay-10min.pptx
+++ b/presentations/Hanui-Relay-10min.pptx
@@ -673,7 +673,7 @@
           <a:p/>
           <a:p>
             <a:r>
-              <a:t>“다음 방문에서는 Luna High가 실제 공개 병원 정보를 찾아 이름·주소·추천 근거와 전화·예약 링크를 보여줍니다. 사용자가 고른 병원과 희망 시간은 예약 준비로 저장합니다. 병원 접수는 외부에서 진행하고, 사용자가 확정됐다고 보고해야 상태를 바꿉니다. 자체 캘린더에서 개인 일정 추가·변경·삭제, ICS 내보내기를 할 수 있습니다.” 화면: 병원 카드 또는 달력.</a:t>
+              <a:t>“다음 방문에서는 에이전트가 실제 공개 병원 정보를 찾아 이름·주소·추천 근거와 전화·예약 링크를 보여줍니다. 사용자가 고른 병원과 희망 시간은 예약 준비로 저장합니다. 병원 접수는 외부에서 진행하고, 사용자가 확정됐다고 보고해야 상태를 바꿉니다. 자체 캘린더에서 개인 일정 추가·변경·삭제, ICS 내보내기를 할 수 있습니다.” 화면: 병원 카드 또는 달력.</a:t>
             </a:r>
           </a:p>
         </p:txBody>
@@ -749,7 +749,7 @@
           <a:p/>
           <a:p>
             <a:r>
-              <a:t>“80개 단위 테스트를 통과했습니다. 실제 Luna 계정으로 선행 질문·환자 답변·코칭의 연결 1회, 지침 대화 4턴, 달력 8턴, 새 고문헌 번역 1턴을 확인했습니다. 환자 발언에 없는 수치를 추측하지 않는 규칙과 실패 시 되돌림도 검사했습니다. 14일·병원·환자는 합성 자료이며 실제 사용자 편익과 임상 해석은 아직 검증하지 않았습니다.”</a:t>
+              <a:t>“80개 단위 테스트를 통과했습니다. 실제 에이전트 연동으로 선행 질문·환자 답변·코칭의 연결 1회, 지침 대화 4턴, 달력 8턴, 새 고문헌 번역 1턴을 확인했습니다. 환자 발언에 없는 수치를 추측하지 않는 규칙과 실패 시 되돌림도 검사했습니다. 14일·병원·환자는 합성 자료이며 실제 사용자 편익과 임상 해석은 아직 검증하지 않았습니다.”</a:t>
             </a:r>
           </a:p>
         </p:txBody>
@@ -825,7 +825,7 @@
           <a:p/>
           <a:p>
             <a:r>
-              <a:t>“서브 에이전트로 고전 문헌탐색, 메인: UI·백엔드 구현을 진행했습니다. 메인 Codex가 수집 원전 판본과 실제 인용 문자 위치, 환자 원문·날짜·수치를 대조하고 단위·UI·실제 Luna 연동을 검증했습니다. 모바일 넘침·대비와 실패 복원도 확인했습니다. 사용자 가독성 피드백으로 대화창을 키우고 덜 중요한 정보는 접었습니다. 상충 발언은 보류하며 질문만으로 환자 사실을 만들지 않습니다.”</a:t>
+              <a:t>“서브 에이전트로 고전 문헌탐색, 메인: UI·백엔드 구현을 진행했습니다. 메인 Codex가 수집 원전 판본과 실제 인용 문자 위치, 환자 원문·날짜·수치를 대조하고 단위·UI·실제 에이전트 연동을 검증했습니다. 모바일 넘침·대비와 실패 복원도 확인했습니다. 사용자 가독성 피드백으로 대화창을 키우고 덜 중요한 정보는 접었습니다. 상충 발언은 보류하며 질문만으로 환자 사실을 만들지 않습니다.”</a:t>
             </a:r>
           </a:p>
         </p:txBody>
@@ -1205,7 +1205,7 @@
           <a:p/>
           <a:p>
             <a:r>
-              <a:t>“서비스 모델은 현재 ChatGPT 로그인으로 호출하는 GPT-6 Luna, high입니다. 의료진 평가로 첫 질문을 고르고, 환자 답변에서 기록 후보와 DB 검색어를 정합니다. 서버는 환자 원문의 날짜·수치를 재계산하고 고문헌 인용 문자열·위치를 확인합니다. 모든 Luna 답변에서 고전 원문을 찾고 검증된 인용을 요구하며, 없으면 답변을 보류합니다. AI는 의료진 진단을 임의로 갱신하지 않습니다.”</a:t>
+              <a:t>“현재 ChatGPT 계정으로 실행하는 OpenAI 에이전트입니다. 의료진 평가로 첫 질문을 고르고, 환자 답변에서 기록 후보와 DB 검색어를 정합니다. 서버는 환자 원문의 날짜·수치를 재계산하고 고문헌 인용 문자열·위치를 확인합니다. 모든 에이전트 답변에서 고전 원문을 찾고 검증된 인용을 요구하며, 없으면 답변을 보류합니다. AI는 의료진 진단을 임의로 갱신하지 않습니다.”</a:t>
             </a:r>
           </a:p>
         </p:txBody>
@@ -1281,7 +1281,7 @@
           <a:p/>
           <a:p>
             <a:r>
-              <a:t>“SQLite에는 현대 자료의 자체 요약 42건, 고문헌 원문 발췌 57건, 모두 99건이 있습니다. 동의보감, 황제내경, 신농본초경의 고정 Wikisource 판본을 담았습니다. Luna가 한국어로 읽어 주고 원문 위치를 제시합니다. 원문 문자 일치는 검사하지만 해석의 의학적 타당성까지 자동 검증하지는 않습니다.”</a:t>
+              <a:t>“SQLite에는 현대 자료의 자체 요약 42건, 고문헌 원문 발췌 57건, 모두 99건이 있습니다. 동의보감, 황제내경, 신농본초경의 고정 Wikisource 판본을 담았습니다. 에이전트가 한국어로 읽어 주고 원문 위치를 제시합니다. 원문 문자 일치는 검사하지만 해석의 의학적 타당성까지 자동 검증하지는 않습니다.”</a:t>
             </a:r>
           </a:p>
         </p:txBody>
@@ -5958,7 +5958,7 @@
       </p:sp>
       <p:pic>
         <p:nvPicPr>
-          <p:cNvPr id="9" name="Picture 8" descr="showcase-calendar-crop-0-1337.png"/>
+          <p:cNvPr id="9" name="Picture 8" descr="showcase-calendar-crop-379-1337.png"/>
           <p:cNvPicPr>
             <a:picLocks noChangeAspect="1"/>
           </p:cNvPicPr>
@@ -5972,8 +5972,8 @@
         </p:blipFill>
         <p:spPr>
           <a:xfrm>
-            <a:off x="6157174" y="1728216"/>
-            <a:ext cx="4766643" cy="4425696"/>
+            <a:off x="5715000" y="2061324"/>
+            <a:ext cx="5650992" cy="3759479"/>
           </a:xfrm>
           <a:prstGeom prst="rect">
             <a:avLst/>
@@ -6059,7 +6059,7 @@
               </a:defRPr>
             </a:pPr>
             <a:r>
-              <a:t>Luna High의 실제 공개 정보 검색</a:t>
+              <a:t>에이전트의 실제 공개 정보 검색</a:t>
             </a:r>
           </a:p>
         </p:txBody>
@@ -6759,7 +6759,7 @@
               </a:defRPr>
             </a:pPr>
             <a:r>
-              <a:t>실제 Luna 선행질문→코칭 1회</a:t>
+              <a:t>실제 에이전트 선행질문→코칭 1회</a:t>
             </a:r>
           </a:p>
           <a:p>
@@ -7407,7 +7407,7 @@
               </a:defRPr>
             </a:pPr>
             <a:r>
-              <a:t>메인: UI·백엔드 구현, 단위·화면·Luna 연동 검증</a:t>
+              <a:t>메인: UI·백엔드 구현, 단위·화면·에이전트 연동 검증</a:t>
             </a:r>
           </a:p>
         </p:txBody>
@@ -10294,7 +10294,7 @@
               </a:defRPr>
             </a:pPr>
             <a:r>
-              <a:t>Luna High가 고르고, 서버가 원문을 검증한다</a:t>
+              <a:t>에이전트가 고르고, 서버가 원문을 검증한다</a:t>
             </a:r>
           </a:p>
         </p:txBody>
@@ -10501,7 +10501,7 @@
               </a:defRPr>
             </a:pPr>
             <a:r>
-              <a:t>Luna High</a:t>
+              <a:t>에이전트</a:t>
             </a:r>
           </a:p>
         </p:txBody>
@@ -10768,7 +10768,7 @@
               </a:defRPr>
             </a:pPr>
             <a:r>
-              <a:t>공식 Codex CLI / 현재 ChatGPT 계정 / gpt-6-luna · high · OpenAI</a:t>
+              <a:t>현재 ChatGPT 계정으로 실행하는 OpenAI 에이전트</a:t>
             </a:r>
           </a:p>
         </p:txBody>

</xml_diff>